<commit_message>
docs(chapter1): replace demo requests with organization registration in business assumptions
</commit_message>
<xml_diff>
--- a/assets/diagrams/lean-ux-canvas/Lean-UX-canvas.pptx
+++ b/assets/diagrams/lean-ux-canvas/Lean-UX-canvas.pptx
@@ -554,10 +554,10 @@
           </a:ln>
           <a:extLst>
             <a:ext uri="{FAA26D3D-D897-4be2-8F04-BA451C77F1D7}">
-              <ma14:placeholderFlag xmlns="" xmlns:ma14="http://schemas.microsoft.com/office/mac/drawingml/2011/main" val="1"/>
+              <ma14:placeholderFlag xmlns:ma14="http://schemas.microsoft.com/office/mac/drawingml/2011/main" xmlns="" val="1"/>
             </a:ext>
             <a:ext uri="{909E8E84-426E-40dd-AFC4-6F175D3DCCD1}">
-              <a14:hiddenFill xmlns:a14="http://schemas.microsoft.com/office/drawing/2010/main" xmlns="">
+              <a14:hiddenFill xmlns="" xmlns:a14="http://schemas.microsoft.com/office/drawing/2010/main">
                 <a:solidFill>
                   <a:srgbClr val="FFFFFF"/>
                 </a:solidFill>
@@ -3633,17 +3633,17 @@
           </a:ln>
           <a:extLst>
             <a:ext uri="{FAA26D3D-D897-4be2-8F04-BA451C77F1D7}">
-              <ma14:placeholderFlag xmlns="" xmlns:ma14="http://schemas.microsoft.com/office/mac/drawingml/2011/main" val="1"/>
+              <ma14:placeholderFlag xmlns:ma14="http://schemas.microsoft.com/office/mac/drawingml/2011/main" xmlns="" val="1"/>
             </a:ext>
             <a:ext uri="{909E8E84-426E-40dd-AFC4-6F175D3DCCD1}">
-              <a14:hiddenFill xmlns:a14="http://schemas.microsoft.com/office/drawing/2010/main" xmlns="">
+              <a14:hiddenFill xmlns="" xmlns:a14="http://schemas.microsoft.com/office/drawing/2010/main">
                 <a:solidFill>
                   <a:srgbClr val="FFFFFF"/>
                 </a:solidFill>
               </a14:hiddenFill>
             </a:ext>
             <a:ext uri="{91240B29-F687-4f45-9708-019B960494DF}">
-              <a14:hiddenLine xmlns:a14="http://schemas.microsoft.com/office/drawing/2010/main" xmlns="" w="9525">
+              <a14:hiddenLine xmlns="" xmlns:a14="http://schemas.microsoft.com/office/drawing/2010/main" w="9525">
                 <a:solidFill>
                   <a:srgbClr val="000000"/>
                 </a:solidFill>
@@ -3694,17 +3694,17 @@
           </a:ln>
           <a:extLst>
             <a:ext uri="{FAA26D3D-D897-4be2-8F04-BA451C77F1D7}">
-              <ma14:placeholderFlag xmlns="" xmlns:ma14="http://schemas.microsoft.com/office/mac/drawingml/2011/main" val="1"/>
+              <ma14:placeholderFlag xmlns:ma14="http://schemas.microsoft.com/office/mac/drawingml/2011/main" xmlns="" val="1"/>
             </a:ext>
             <a:ext uri="{909E8E84-426E-40dd-AFC4-6F175D3DCCD1}">
-              <a14:hiddenFill xmlns:a14="http://schemas.microsoft.com/office/drawing/2010/main" xmlns="">
+              <a14:hiddenFill xmlns="" xmlns:a14="http://schemas.microsoft.com/office/drawing/2010/main">
                 <a:solidFill>
                   <a:srgbClr val="FFFFFF"/>
                 </a:solidFill>
               </a14:hiddenFill>
             </a:ext>
             <a:ext uri="{91240B29-F687-4f45-9708-019B960494DF}">
-              <a14:hiddenLine xmlns:a14="http://schemas.microsoft.com/office/drawing/2010/main" xmlns="" w="9525">
+              <a14:hiddenLine xmlns="" xmlns:a14="http://schemas.microsoft.com/office/drawing/2010/main" w="9525">
                 <a:solidFill>
                   <a:srgbClr val="000000"/>
                 </a:solidFill>
@@ -4400,14 +4400,14 @@
           </a:ln>
           <a:extLst>
             <a:ext uri="{909E8E84-426E-40dd-AFC4-6F175D3DCCD1}">
-              <a14:hiddenFill xmlns:a14="http://schemas.microsoft.com/office/drawing/2010/main" xmlns="">
+              <a14:hiddenFill xmlns="" xmlns:a14="http://schemas.microsoft.com/office/drawing/2010/main">
                 <a:solidFill>
                   <a:srgbClr val="FFFFFF"/>
                 </a:solidFill>
               </a14:hiddenFill>
             </a:ext>
             <a:ext uri="{91240B29-F687-4f45-9708-019B960494DF}">
-              <a14:hiddenLine xmlns:a14="http://schemas.microsoft.com/office/drawing/2010/main" xmlns="" w="9525">
+              <a14:hiddenLine xmlns="" xmlns:a14="http://schemas.microsoft.com/office/drawing/2010/main" w="9525">
                 <a:solidFill>
                   <a:srgbClr val="000000"/>
                 </a:solidFill>
@@ -5762,14 +5762,23 @@
               <a:rPr lang="en-US" sz="700" b="1" dirty="0">
                 <a:latin typeface="Helvetica Neue"/>
               </a:rPr>
-              <a:t>Metric: </a:t>
-            </a:r>
-            <a:r>
-              <a:rPr lang="en-US" sz="700" dirty="0">
-                <a:latin typeface="Helvetica Neue"/>
-              </a:rPr>
-              <a:t>Number of demo requests, contact submissions, and interview participants recruited.</a:t>
-            </a:r>
+              <a:t>Metric</a:t>
+            </a:r>
+            <a:r>
+              <a:rPr lang="en-US" sz="700" b="1">
+                <a:latin typeface="Helvetica Neue"/>
+              </a:rPr>
+              <a:t>: </a:t>
+            </a:r>
+            <a:r>
+              <a:rPr lang="en-US" sz="700">
+                <a:latin typeface="Helvetica Neue"/>
+              </a:rPr>
+              <a:t>Number of contact inquiries, organization registrations, and interview participants recruited.</a:t>
+            </a:r>
+            <a:endParaRPr lang="en-US" sz="700" dirty="0">
+              <a:latin typeface="Helvetica Neue"/>
+            </a:endParaRPr>
           </a:p>
           <a:p>
             <a:pPr marL="171450" indent="-171450" algn="just">
@@ -8350,7 +8359,7 @@
           </a:ln>
           <a:extLst>
             <a:ext uri="{91240B29-F687-4f45-9708-019B960494DF}">
-              <a14:hiddenLine xmlns:a14="http://schemas.microsoft.com/office/drawing/2010/main" xmlns="" w="3175">
+              <a14:hiddenLine xmlns="" xmlns:a14="http://schemas.microsoft.com/office/drawing/2010/main" w="3175">
                 <a:solidFill>
                   <a:srgbClr val="000000"/>
                 </a:solidFill>
@@ -8409,7 +8418,7 @@
           </a:ln>
           <a:extLst>
             <a:ext uri="{91240B29-F687-4f45-9708-019B960494DF}">
-              <a14:hiddenLine xmlns:a14="http://schemas.microsoft.com/office/drawing/2010/main" xmlns="" w="3175">
+              <a14:hiddenLine xmlns="" xmlns:a14="http://schemas.microsoft.com/office/drawing/2010/main" w="3175">
                 <a:solidFill>
                   <a:srgbClr val="000000"/>
                 </a:solidFill>
@@ -8479,7 +8488,7 @@
           </a:ln>
           <a:extLst>
             <a:ext uri="{91240B29-F687-4f45-9708-019B960494DF}">
-              <a14:hiddenLine xmlns:a14="http://schemas.microsoft.com/office/drawing/2010/main" xmlns="" w="3175">
+              <a14:hiddenLine xmlns="" xmlns:a14="http://schemas.microsoft.com/office/drawing/2010/main" w="3175">
                 <a:solidFill>
                   <a:srgbClr val="000000"/>
                 </a:solidFill>

</xml_diff>